<commit_message>
Replace slogan slide with a slogan for each positioning point
Co-Authored-By: Claude Opus 5.5 <noreply@anthropic.com>
Claude-Session: https://claude.ai/code/session_01TPggK9YYJAqPjj1kZSx5tS
</commit_message>
<xml_diff>
--- a/Фотокорпус (редактируемая).pptx
+++ b/Фотокорпус (редактируемая).pptx
@@ -114,12 +114,12 @@
   <p:extLst>
     <p:ext uri="{521415D9-36F7-43E2-AB2F-B90AF26B5E84}">
       <p14:sectionLst xmlns:p14="http://schemas.microsoft.com/office/powerpoint/2010/main">
-        <p14:section name="Титул" id="{63edea59-f11c-cf7e-1012-6ba9fe401794}">
+        <p14:section name="Титул" id="{43800794-4756-fb28-5ab3-8753b66148f2}">
           <p14:sldIdLst>
             <p14:sldId id="256"/>
           </p14:sldIdLst>
         </p14:section>
-        <p14:section name="Бизнес-модель" id="{e3a8e416-f186-72d3-501f-8ad79b237cac}">
+        <p14:section name="Бизнес-модель" id="{b2d0d071-8aac-028c-58a6-668c16fb4462}">
           <p14:sldIdLst>
             <p14:sldId id="257"/>
             <p14:sldId id="258"/>
@@ -127,12 +127,12 @@
             <p14:sldId id="260"/>
           </p14:sldIdLst>
         </p14:section>
-        <p14:section name="Позиционирование" id="{f8fdb223-538b-28aa-c8fe-7af248a470e9}">
+        <p14:section name="Позиционирование" id="{00b6181f-c819-5b80-9b8f-594844531182}">
           <p14:sldIdLst>
             <p14:sldId id="261"/>
           </p14:sldIdLst>
         </p14:section>
-        <p14:section name="Айдентика" id="{8e73d62e-3fb6-f357-12a3-ad468b70d003}">
+        <p14:section name="Айдентика" id="{bf336e4b-f841-0073-0a51-019ee997f684}">
           <p14:sldIdLst>
             <p14:sldId id="262"/>
             <p14:sldId id="263"/>
@@ -8482,7 +8482,7 @@
                   <a:schemeClr val="accent1"/>
                 </a:solidFill>
               </a:rPr>
-              <a:t>6 · СЛОГАН</a:t>
+              <a:t>6 · СЛОГАНЫ</a:t>
             </a:r>
             <a:endParaRPr lang="en-US" sz="1100" dirty="0"/>
           </a:p>
@@ -8523,7 +8523,7 @@
                 <a:ea typeface="Arial Black" pitchFamily="34" charset="-122"/>
                 <a:cs typeface="Arial Black" pitchFamily="34" charset="-120"/>
               </a:rPr>
-              <a:t>Две фразы — два отличия</a:t>
+              <a:t>Фраза к каждому пункту позиционирования</a:t>
             </a:r>
             <a:endParaRPr lang="en-US" sz="2800" dirty="0"/>
           </a:p>
@@ -8531,92 +8531,14 @@
       </p:sp>
       <p:sp>
         <p:nvSpPr>
-          <p:cNvPr id="4" name="Text 2"/>
-          <p:cNvSpPr txBox="1"/>
+          <p:cNvPr id="4" name="Shape 2"/>
+          <p:cNvSpPr/>
           <p:nvPr/>
         </p:nvSpPr>
         <p:spPr>
           <a:xfrm>
             <a:off x="548640" y="1600200"/>
-            <a:ext cx="5852160" cy="4663440"/>
-          </a:xfrm>
-          <a:prstGeom prst="rect">
-            <a:avLst/>
-          </a:prstGeom>
-          <a:noFill/>
-          <a:ln/>
-        </p:spPr>
-        <p:txBody>
-          <a:bodyPr wrap="square" lIns="0" tIns="0" rIns="0" bIns="0" rtlCol="0" anchor="ctr"/>
-          <a:lstStyle/>
-          <a:p>
-            <a:pPr indent="0" marL="0">
-              <a:buNone/>
-            </a:pPr>
-            <a:r>
-              <a:rPr lang="en-US" sz="4600" dirty="0">
-                <a:solidFill>
-                  <a:schemeClr val="accent1"/>
-                </a:solidFill>
-                <a:latin typeface="Arial Black" pitchFamily="34" charset="0"/>
-                <a:ea typeface="Arial Black" pitchFamily="34" charset="-122"/>
-                <a:cs typeface="Arial Black" pitchFamily="34" charset="-120"/>
-              </a:rPr>
-              <a:t>«Снято честно. Проверено кликом.»</a:t>
-            </a:r>
-            <a:endParaRPr lang="en-US" sz="4600" dirty="0"/>
-          </a:p>
-        </p:txBody>
-      </p:sp>
-      <p:sp>
-        <p:nvSpPr>
-          <p:cNvPr id="5" name="Text 3"/>
-          <p:cNvSpPr txBox="1"/>
-          <p:nvPr/>
-        </p:nvSpPr>
-        <p:spPr>
-          <a:xfrm>
-            <a:off x="6812280" y="1600200"/>
-            <a:ext cx="4830775" cy="274320"/>
-          </a:xfrm>
-          <a:prstGeom prst="rect">
-            <a:avLst/>
-          </a:prstGeom>
-          <a:noFill/>
-          <a:ln/>
-        </p:spPr>
-        <p:txBody>
-          <a:bodyPr wrap="square" lIns="0" tIns="0" rIns="0" bIns="0" rtlCol="0" anchor="t"/>
-          <a:lstStyle/>
-          <a:p>
-            <a:pPr indent="0" marL="0">
-              <a:buNone/>
-            </a:pPr>
-            <a:r>
-              <a:rPr lang="en-US" sz="1100" b="1" spc="200" kern="0" dirty="0">
-                <a:solidFill>
-                  <a:schemeClr val="accent1"/>
-                </a:solidFill>
-                <a:latin typeface="Arial" pitchFamily="34" charset="0"/>
-                <a:ea typeface="Arial" pitchFamily="34" charset="-122"/>
-                <a:cs typeface="Arial" pitchFamily="34" charset="-120"/>
-              </a:rPr>
-              <a:t>ПОЧЕМУ ЭТОТ</a:t>
-            </a:r>
-            <a:endParaRPr lang="en-US" sz="1100" dirty="0"/>
-          </a:p>
-        </p:txBody>
-      </p:sp>
-      <p:sp>
-        <p:nvSpPr>
-          <p:cNvPr id="6" name="Shape 4"/>
-          <p:cNvSpPr/>
-          <p:nvPr/>
-        </p:nvSpPr>
-        <p:spPr>
-          <a:xfrm>
-            <a:off x="6812280" y="2011680"/>
-            <a:ext cx="4830775" cy="0"/>
+            <a:ext cx="11094415" cy="0"/>
           </a:xfrm>
           <a:prstGeom prst="line">
             <a:avLst/>
@@ -8632,92 +8554,14 @@
       </p:sp>
       <p:sp>
         <p:nvSpPr>
-          <p:cNvPr id="7" name="Text 5"/>
-          <p:cNvSpPr txBox="1"/>
-          <p:nvPr/>
-        </p:nvSpPr>
-        <p:spPr>
-          <a:xfrm>
-            <a:off x="6812280" y="2176272"/>
-            <a:ext cx="457200" cy="274320"/>
-          </a:xfrm>
-          <a:prstGeom prst="rect">
-            <a:avLst/>
-          </a:prstGeom>
-          <a:noFill/>
-          <a:ln/>
-        </p:spPr>
-        <p:txBody>
-          <a:bodyPr wrap="square" lIns="0" tIns="0" rIns="0" bIns="0" rtlCol="0" anchor="t"/>
-          <a:lstStyle/>
-          <a:p>
-            <a:pPr indent="0" marL="0">
-              <a:buNone/>
-            </a:pPr>
-            <a:r>
-              <a:rPr lang="en-US" sz="1200" dirty="0">
-                <a:solidFill>
-                  <a:schemeClr val="accent1"/>
-                </a:solidFill>
-                <a:latin typeface="Arial Black" pitchFamily="34" charset="0"/>
-                <a:ea typeface="Arial Black" pitchFamily="34" charset="-122"/>
-                <a:cs typeface="Arial Black" pitchFamily="34" charset="-120"/>
-              </a:rPr>
-              <a:t>01</a:t>
-            </a:r>
-            <a:endParaRPr lang="en-US" sz="1200" dirty="0"/>
-          </a:p>
-        </p:txBody>
-      </p:sp>
-      <p:sp>
-        <p:nvSpPr>
-          <p:cNvPr id="8" name="Text 6"/>
-          <p:cNvSpPr txBox="1"/>
-          <p:nvPr/>
-        </p:nvSpPr>
-        <p:spPr>
-          <a:xfrm>
-            <a:off x="7360920" y="2148840"/>
-            <a:ext cx="4282135" cy="640080"/>
-          </a:xfrm>
-          <a:prstGeom prst="rect">
-            <a:avLst/>
-          </a:prstGeom>
-          <a:noFill/>
-          <a:ln/>
-        </p:spPr>
-        <p:txBody>
-          <a:bodyPr wrap="square" lIns="0" tIns="0" rIns="0" bIns="0" rtlCol="0" anchor="t"/>
-          <a:lstStyle/>
-          <a:p>
-            <a:pPr indent="0" marL="0">
-              <a:buNone/>
-            </a:pPr>
-            <a:r>
-              <a:rPr lang="en-US" sz="1500" dirty="0">
-                <a:solidFill>
-                  <a:schemeClr val="tx1"/>
-                </a:solidFill>
-                <a:latin typeface="Arial" pitchFamily="34" charset="0"/>
-                <a:ea typeface="Arial" pitchFamily="34" charset="-122"/>
-                <a:cs typeface="Arial" pitchFamily="34" charset="-120"/>
-              </a:rPr>
-              <a:t>«Снято честно» — реальный товар; «проверено кликом» — обложка, прошедшая A/B-тест</a:t>
-            </a:r>
-            <a:endParaRPr lang="en-US" sz="1500" dirty="0"/>
-          </a:p>
-        </p:txBody>
-      </p:sp>
-      <p:sp>
-        <p:nvSpPr>
-          <p:cNvPr id="9" name="Shape 7"/>
+          <p:cNvPr id="5" name="Shape 3"/>
           <p:cNvSpPr/>
           <p:nvPr/>
         </p:nvSpPr>
         <p:spPr>
           <a:xfrm>
-            <a:off x="6812280" y="2999232"/>
-            <a:ext cx="4830775" cy="0"/>
+            <a:off x="548640" y="2266406"/>
+            <a:ext cx="11094415" cy="0"/>
           </a:xfrm>
           <a:prstGeom prst="line">
             <a:avLst/>
@@ -8733,92 +8577,92 @@
       </p:sp>
       <p:sp>
         <p:nvSpPr>
-          <p:cNvPr id="10" name="Text 8"/>
+          <p:cNvPr id="6" name="Text 4"/>
           <p:cNvSpPr txBox="1"/>
           <p:nvPr/>
         </p:nvSpPr>
         <p:spPr>
           <a:xfrm>
-            <a:off x="6812280" y="3163824"/>
-            <a:ext cx="457200" cy="274320"/>
-          </a:xfrm>
-          <a:prstGeom prst="rect">
-            <a:avLst/>
-          </a:prstGeom>
-          <a:noFill/>
-          <a:ln/>
-        </p:spPr>
-        <p:txBody>
-          <a:bodyPr wrap="square" lIns="0" tIns="0" rIns="0" bIns="0" rtlCol="0" anchor="t"/>
-          <a:lstStyle/>
-          <a:p>
-            <a:pPr indent="0" marL="0">
-              <a:buNone/>
-            </a:pPr>
-            <a:r>
-              <a:rPr lang="en-US" sz="1200" dirty="0">
+            <a:off x="731520" y="1600200"/>
+            <a:ext cx="2377440" cy="666206"/>
+          </a:xfrm>
+          <a:prstGeom prst="rect">
+            <a:avLst/>
+          </a:prstGeom>
+          <a:noFill/>
+          <a:ln/>
+        </p:spPr>
+        <p:txBody>
+          <a:bodyPr wrap="square" lIns="0" tIns="0" rIns="0" bIns="0" rtlCol="0" anchor="ctr"/>
+          <a:lstStyle/>
+          <a:p>
+            <a:pPr indent="0" marL="0">
+              <a:buNone/>
+            </a:pPr>
+            <a:r>
+              <a:rPr lang="en-US" sz="1000" b="1" spc="150" kern="0" dirty="0">
                 <a:solidFill>
                   <a:schemeClr val="accent1"/>
+                </a:solidFill>
+                <a:latin typeface="Arial" pitchFamily="34" charset="0"/>
+                <a:ea typeface="Arial" pitchFamily="34" charset="-122"/>
+                <a:cs typeface="Arial" pitchFamily="34" charset="-120"/>
+              </a:rPr>
+              <a:t>1 · ПО АТРИБУТУ</a:t>
+            </a:r>
+            <a:endParaRPr lang="en-US" sz="1000" dirty="0"/>
+          </a:p>
+        </p:txBody>
+      </p:sp>
+      <p:sp>
+        <p:nvSpPr>
+          <p:cNvPr id="7" name="Text 5"/>
+          <p:cNvSpPr txBox="1"/>
+          <p:nvPr/>
+        </p:nvSpPr>
+        <p:spPr>
+          <a:xfrm>
+            <a:off x="3200400" y="1600200"/>
+            <a:ext cx="6766560" cy="666206"/>
+          </a:xfrm>
+          <a:prstGeom prst="rect">
+            <a:avLst/>
+          </a:prstGeom>
+          <a:noFill/>
+          <a:ln/>
+        </p:spPr>
+        <p:txBody>
+          <a:bodyPr wrap="square" lIns="0" tIns="0" rIns="0" bIns="0" rtlCol="0" anchor="ctr"/>
+          <a:lstStyle/>
+          <a:p>
+            <a:pPr indent="0" marL="0">
+              <a:buNone/>
+            </a:pPr>
+            <a:r>
+              <a:rPr lang="en-US" sz="2000" dirty="0">
+                <a:solidFill>
+                  <a:schemeClr val="tx1"/>
                 </a:solidFill>
                 <a:latin typeface="Arial Black" pitchFamily="34" charset="0"/>
                 <a:ea typeface="Arial Black" pitchFamily="34" charset="-122"/>
                 <a:cs typeface="Arial Black" pitchFamily="34" charset="-120"/>
               </a:rPr>
-              <a:t>02</a:t>
-            </a:r>
-            <a:endParaRPr lang="en-US" sz="1200" dirty="0"/>
-          </a:p>
-        </p:txBody>
-      </p:sp>
-      <p:sp>
-        <p:nvSpPr>
-          <p:cNvPr id="11" name="Text 9"/>
-          <p:cNvSpPr txBox="1"/>
-          <p:nvPr/>
-        </p:nvSpPr>
-        <p:spPr>
-          <a:xfrm>
-            <a:off x="7360920" y="3136392"/>
-            <a:ext cx="4282135" cy="640080"/>
-          </a:xfrm>
-          <a:prstGeom prst="rect">
-            <a:avLst/>
-          </a:prstGeom>
-          <a:noFill/>
-          <a:ln/>
-        </p:spPr>
-        <p:txBody>
-          <a:bodyPr wrap="square" lIns="0" tIns="0" rIns="0" bIns="0" rtlCol="0" anchor="t"/>
-          <a:lstStyle/>
-          <a:p>
-            <a:pPr indent="0" marL="0">
-              <a:buNone/>
-            </a:pPr>
-            <a:r>
-              <a:rPr lang="en-US" sz="1500" dirty="0">
-                <a:solidFill>
-                  <a:schemeClr val="tx1"/>
-                </a:solidFill>
-                <a:latin typeface="Arial" pitchFamily="34" charset="0"/>
-                <a:ea typeface="Arial" pitchFamily="34" charset="-122"/>
-                <a:cs typeface="Arial" pitchFamily="34" charset="-120"/>
-              </a:rPr>
-              <a:t>«Клик» — слово из мира продавца: CTR, кликабельность</a:t>
-            </a:r>
-            <a:endParaRPr lang="en-US" sz="1500" dirty="0"/>
-          </a:p>
-        </p:txBody>
-      </p:sp>
-      <p:sp>
-        <p:nvSpPr>
-          <p:cNvPr id="12" name="Shape 10"/>
+              <a:t>«Готовая. Продающая. Честная.»</a:t>
+            </a:r>
+            <a:endParaRPr lang="en-US" sz="2000" dirty="0"/>
+          </a:p>
+        </p:txBody>
+      </p:sp>
+      <p:sp>
+        <p:nvSpPr>
+          <p:cNvPr id="8" name="Shape 6"/>
           <p:cNvSpPr/>
           <p:nvPr/>
         </p:nvSpPr>
         <p:spPr>
           <a:xfrm>
-            <a:off x="6812280" y="3986784"/>
-            <a:ext cx="4830775" cy="0"/>
+            <a:off x="548640" y="2932611"/>
+            <a:ext cx="11094415" cy="0"/>
           </a:xfrm>
           <a:prstGeom prst="line">
             <a:avLst/>
@@ -8834,101 +8678,97 @@
       </p:sp>
       <p:sp>
         <p:nvSpPr>
-          <p:cNvPr id="13" name="Text 11"/>
+          <p:cNvPr id="9" name="Text 7"/>
           <p:cNvSpPr txBox="1"/>
           <p:nvPr/>
         </p:nvSpPr>
         <p:spPr>
           <a:xfrm>
-            <a:off x="6812280" y="4151376"/>
-            <a:ext cx="457200" cy="274320"/>
-          </a:xfrm>
-          <a:prstGeom prst="rect">
-            <a:avLst/>
-          </a:prstGeom>
-          <a:noFill/>
-          <a:ln/>
-        </p:spPr>
-        <p:txBody>
-          <a:bodyPr wrap="square" lIns="0" tIns="0" rIns="0" bIns="0" rtlCol="0" anchor="t"/>
-          <a:lstStyle/>
-          <a:p>
-            <a:pPr indent="0" marL="0">
-              <a:buNone/>
-            </a:pPr>
-            <a:r>
-              <a:rPr lang="en-US" sz="1200" dirty="0">
+            <a:off x="731520" y="2266406"/>
+            <a:ext cx="2377440" cy="666206"/>
+          </a:xfrm>
+          <a:prstGeom prst="rect">
+            <a:avLst/>
+          </a:prstGeom>
+          <a:noFill/>
+          <a:ln/>
+        </p:spPr>
+        <p:txBody>
+          <a:bodyPr wrap="square" lIns="0" tIns="0" rIns="0" bIns="0" rtlCol="0" anchor="ctr"/>
+          <a:lstStyle/>
+          <a:p>
+            <a:pPr indent="0" marL="0">
+              <a:buNone/>
+            </a:pPr>
+            <a:r>
+              <a:rPr lang="en-US" sz="1000" b="1" spc="150" kern="0" dirty="0">
                 <a:solidFill>
                   <a:schemeClr val="accent1"/>
+                </a:solidFill>
+                <a:latin typeface="Arial" pitchFamily="34" charset="0"/>
+                <a:ea typeface="Arial" pitchFamily="34" charset="-122"/>
+                <a:cs typeface="Arial" pitchFamily="34" charset="-120"/>
+              </a:rPr>
+              <a:t>2 · ПО ПРИМЕНЕНИЮ</a:t>
+            </a:r>
+            <a:endParaRPr lang="en-US" sz="1000" dirty="0"/>
+          </a:p>
+        </p:txBody>
+      </p:sp>
+      <p:sp>
+        <p:nvSpPr>
+          <p:cNvPr id="10" name="Text 8"/>
+          <p:cNvSpPr txBox="1"/>
+          <p:nvPr/>
+        </p:nvSpPr>
+        <p:spPr>
+          <a:xfrm>
+            <a:off x="3200400" y="2266406"/>
+            <a:ext cx="6766560" cy="666206"/>
+          </a:xfrm>
+          <a:prstGeom prst="rect">
+            <a:avLst/>
+          </a:prstGeom>
+          <a:noFill/>
+          <a:ln/>
+        </p:spPr>
+        <p:txBody>
+          <a:bodyPr wrap="square" lIns="0" tIns="0" rIns="0" bIns="0" rtlCol="0" anchor="ctr"/>
+          <a:lstStyle/>
+          <a:p>
+            <a:pPr indent="0" marL="0">
+              <a:buNone/>
+            </a:pPr>
+            <a:r>
+              <a:rPr lang="en-US" sz="2000" dirty="0">
+                <a:solidFill>
+                  <a:schemeClr val="tx1"/>
                 </a:solidFill>
                 <a:latin typeface="Arial Black" pitchFamily="34" charset="0"/>
                 <a:ea typeface="Arial Black" pitchFamily="34" charset="-122"/>
                 <a:cs typeface="Arial Black" pitchFamily="34" charset="-120"/>
               </a:rPr>
-              <a:t>03</a:t>
-            </a:r>
-            <a:endParaRPr lang="en-US" sz="1200" dirty="0"/>
-          </a:p>
-        </p:txBody>
-      </p:sp>
-      <p:sp>
-        <p:nvSpPr>
-          <p:cNvPr id="14" name="Text 12"/>
-          <p:cNvSpPr txBox="1"/>
-          <p:nvPr/>
-        </p:nvSpPr>
-        <p:spPr>
-          <a:xfrm>
-            <a:off x="7360920" y="4123944"/>
-            <a:ext cx="4282135" cy="640080"/>
-          </a:xfrm>
-          <a:prstGeom prst="rect">
-            <a:avLst/>
-          </a:prstGeom>
-          <a:noFill/>
-          <a:ln/>
-        </p:spPr>
-        <p:txBody>
-          <a:bodyPr wrap="square" lIns="0" tIns="0" rIns="0" bIns="0" rtlCol="0" anchor="t"/>
-          <a:lstStyle/>
-          <a:p>
-            <a:pPr indent="0" marL="0">
-              <a:buNone/>
-            </a:pPr>
-            <a:r>
-              <a:rPr lang="en-US" sz="1500" dirty="0">
-                <a:solidFill>
-                  <a:schemeClr val="tx1"/>
-                </a:solidFill>
-                <a:latin typeface="Arial" pitchFamily="34" charset="0"/>
-                <a:ea typeface="Arial" pitchFamily="34" charset="-122"/>
-                <a:cs typeface="Arial" pitchFamily="34" charset="-120"/>
-              </a:rPr>
-              <a:t>Ритм «два слова + два слова» легко запомнить и повторить</a:t>
-            </a:r>
-            <a:endParaRPr lang="en-US" sz="1500" dirty="0"/>
-          </a:p>
-        </p:txBody>
-      </p:sp>
-      <p:sp>
-        <p:nvSpPr>
-          <p:cNvPr id="15" name="tagline"/>
+              <a:t>«Из показа — в заказ»</a:t>
+            </a:r>
+            <a:endParaRPr lang="en-US" sz="2000" dirty="0"/>
+          </a:p>
+        </p:txBody>
+      </p:sp>
+      <p:sp>
+        <p:nvSpPr>
+          <p:cNvPr id="11" name="Shape 9"/>
           <p:cNvSpPr/>
           <p:nvPr/>
         </p:nvSpPr>
         <p:spPr>
           <a:xfrm>
-            <a:off x="6812280" y="5029200"/>
-            <a:ext cx="4830775" cy="1234440"/>
-          </a:xfrm>
-          <a:prstGeom prst="roundRect">
-            <a:avLst>
-              <a:gd name="adj" fmla="val 4444"/>
-            </a:avLst>
-          </a:prstGeom>
-          <a:solidFill>
-            <a:schemeClr val="bg1"/>
-          </a:solidFill>
+            <a:off x="548640" y="3598817"/>
+            <a:ext cx="11094415" cy="0"/>
+          </a:xfrm>
+          <a:prstGeom prst="line">
+            <a:avLst/>
+          </a:prstGeom>
+          <a:noFill/>
           <a:ln w="9525">
             <a:solidFill>
               <a:schemeClr val="accent4"/>
@@ -8939,23 +8779,23 @@
       </p:sp>
       <p:sp>
         <p:nvSpPr>
-          <p:cNvPr id="16" name="Text 14"/>
+          <p:cNvPr id="12" name="Text 10"/>
           <p:cNvSpPr txBox="1"/>
           <p:nvPr/>
         </p:nvSpPr>
         <p:spPr>
           <a:xfrm>
-            <a:off x="7040880" y="5212080"/>
-            <a:ext cx="4373575" cy="228600"/>
-          </a:xfrm>
-          <a:prstGeom prst="rect">
-            <a:avLst/>
-          </a:prstGeom>
-          <a:noFill/>
-          <a:ln/>
-        </p:spPr>
-        <p:txBody>
-          <a:bodyPr wrap="square" lIns="0" tIns="0" rIns="0" bIns="0" rtlCol="0" anchor="t"/>
+            <a:off x="731520" y="2932611"/>
+            <a:ext cx="2377440" cy="666206"/>
+          </a:xfrm>
+          <a:prstGeom prst="rect">
+            <a:avLst/>
+          </a:prstGeom>
+          <a:noFill/>
+          <a:ln/>
+        </p:spPr>
+        <p:txBody>
+          <a:bodyPr wrap="square" lIns="0" tIns="0" rIns="0" bIns="0" rtlCol="0" anchor="ctr"/>
           <a:lstStyle/>
           <a:p>
             <a:pPr indent="0" marL="0">
@@ -8970,7 +8810,7 @@
                 <a:ea typeface="Arial" pitchFamily="34" charset="-122"/>
                 <a:cs typeface="Arial" pitchFamily="34" charset="-120"/>
               </a:rPr>
-              <a:t>ПОДПИСЬ К УСЛУГЕ</a:t>
+              <a:t>3 · ПО КАТЕГОРИИ</a:t>
             </a:r>
             <a:endParaRPr lang="en-US" sz="1000" dirty="0"/>
           </a:p>
@@ -8978,54 +8818,506 @@
       </p:sp>
       <p:sp>
         <p:nvSpPr>
-          <p:cNvPr id="17" name="Text 15"/>
+          <p:cNvPr id="13" name="Text 11"/>
           <p:cNvSpPr txBox="1"/>
           <p:nvPr/>
         </p:nvSpPr>
         <p:spPr>
           <a:xfrm>
-            <a:off x="7040880" y="5504688"/>
-            <a:ext cx="4373575" cy="640080"/>
-          </a:xfrm>
-          <a:prstGeom prst="rect">
-            <a:avLst/>
-          </a:prstGeom>
-          <a:noFill/>
-          <a:ln/>
-        </p:spPr>
-        <p:txBody>
-          <a:bodyPr wrap="square" lIns="0" tIns="0" rIns="0" bIns="0" rtlCol="0" anchor="t"/>
-          <a:lstStyle/>
-          <a:p>
-            <a:pPr indent="0" marL="0">
-              <a:buNone/>
-            </a:pPr>
-            <a:r>
-              <a:rPr lang="en-US" sz="1250" b="1" dirty="0">
+            <a:off x="3200400" y="2932611"/>
+            <a:ext cx="6766560" cy="666206"/>
+          </a:xfrm>
+          <a:prstGeom prst="rect">
+            <a:avLst/>
+          </a:prstGeom>
+          <a:noFill/>
+          <a:ln/>
+        </p:spPr>
+        <p:txBody>
+          <a:bodyPr wrap="square" lIns="0" tIns="0" rIns="0" bIns="0" rtlCol="0" anchor="ctr"/>
+          <a:lstStyle/>
+          <a:p>
+            <a:pPr indent="0" marL="0">
+              <a:buNone/>
+            </a:pPr>
+            <a:r>
+              <a:rPr lang="en-US" sz="2000" dirty="0">
                 <a:solidFill>
                   <a:schemeClr val="tx1"/>
+                </a:solidFill>
+                <a:latin typeface="Arial Black" pitchFamily="34" charset="0"/>
+                <a:ea typeface="Arial Black" pitchFamily="34" charset="-122"/>
+                <a:cs typeface="Arial Black" pitchFamily="34" charset="-120"/>
+              </a:rPr>
+              <a:t>«Не просто фото, а вся карточка»</a:t>
+            </a:r>
+            <a:endParaRPr lang="en-US" sz="2000" dirty="0"/>
+          </a:p>
+        </p:txBody>
+      </p:sp>
+      <p:sp>
+        <p:nvSpPr>
+          <p:cNvPr id="14" name="Shape 12"/>
+          <p:cNvSpPr/>
+          <p:nvPr/>
+        </p:nvSpPr>
+        <p:spPr>
+          <a:xfrm>
+            <a:off x="548640" y="4265023"/>
+            <a:ext cx="11094415" cy="0"/>
+          </a:xfrm>
+          <a:prstGeom prst="line">
+            <a:avLst/>
+          </a:prstGeom>
+          <a:noFill/>
+          <a:ln w="9525">
+            <a:solidFill>
+              <a:schemeClr val="accent4"/>
+            </a:solidFill>
+            <a:prstDash val="solid"/>
+          </a:ln>
+        </p:spPr>
+      </p:sp>
+      <p:sp>
+        <p:nvSpPr>
+          <p:cNvPr id="15" name="Text 13"/>
+          <p:cNvSpPr txBox="1"/>
+          <p:nvPr/>
+        </p:nvSpPr>
+        <p:spPr>
+          <a:xfrm>
+            <a:off x="731520" y="3598817"/>
+            <a:ext cx="2377440" cy="666206"/>
+          </a:xfrm>
+          <a:prstGeom prst="rect">
+            <a:avLst/>
+          </a:prstGeom>
+          <a:noFill/>
+          <a:ln/>
+        </p:spPr>
+        <p:txBody>
+          <a:bodyPr wrap="square" lIns="0" tIns="0" rIns="0" bIns="0" rtlCol="0" anchor="ctr"/>
+          <a:lstStyle/>
+          <a:p>
+            <a:pPr indent="0" marL="0">
+              <a:buNone/>
+            </a:pPr>
+            <a:r>
+              <a:rPr lang="en-US" sz="1000" b="1" spc="150" kern="0" dirty="0">
+                <a:solidFill>
+                  <a:schemeClr val="accent1"/>
                 </a:solidFill>
                 <a:latin typeface="Arial" pitchFamily="34" charset="0"/>
                 <a:ea typeface="Arial" pitchFamily="34" charset="-122"/>
                 <a:cs typeface="Arial" pitchFamily="34" charset="-120"/>
               </a:rPr>
-              <a:t>«От вещи до карточки»</a:t>
-            </a:r>
-            <a:pPr indent="0" marL="0">
-              <a:buNone/>
-            </a:pPr>
-            <a:r>
-              <a:rPr lang="en-US" sz="1250" dirty="0">
-                <a:solidFill>
-                  <a:schemeClr val="accent3"/>
+              <a:t>4 · ПО ПОТРЕБИТЕЛЮ</a:t>
+            </a:r>
+            <a:endParaRPr lang="en-US" sz="1000" dirty="0"/>
+          </a:p>
+        </p:txBody>
+      </p:sp>
+      <p:sp>
+        <p:nvSpPr>
+          <p:cNvPr id="16" name="Text 14"/>
+          <p:cNvSpPr txBox="1"/>
+          <p:nvPr/>
+        </p:nvSpPr>
+        <p:spPr>
+          <a:xfrm>
+            <a:off x="3200400" y="3598817"/>
+            <a:ext cx="6766560" cy="666206"/>
+          </a:xfrm>
+          <a:prstGeom prst="rect">
+            <a:avLst/>
+          </a:prstGeom>
+          <a:noFill/>
+          <a:ln/>
+        </p:spPr>
+        <p:txBody>
+          <a:bodyPr wrap="square" lIns="0" tIns="0" rIns="0" bIns="0" rtlCol="0" anchor="ctr"/>
+          <a:lstStyle/>
+          <a:p>
+            <a:pPr indent="0" marL="0">
+              <a:buNone/>
+            </a:pPr>
+            <a:r>
+              <a:rPr lang="en-US" sz="2000" dirty="0">
+                <a:solidFill>
+                  <a:schemeClr val="tx1"/>
+                </a:solidFill>
+                <a:latin typeface="Arial Black" pitchFamily="34" charset="0"/>
+                <a:ea typeface="Arial Black" pitchFamily="34" charset="-122"/>
+                <a:cs typeface="Arial Black" pitchFamily="34" charset="-120"/>
+              </a:rPr>
+              <a:t>«Для тех, кто продаёт своё»</a:t>
+            </a:r>
+            <a:endParaRPr lang="en-US" sz="2000" dirty="0"/>
+          </a:p>
+        </p:txBody>
+      </p:sp>
+      <p:sp>
+        <p:nvSpPr>
+          <p:cNvPr id="17" name="Shape 15"/>
+          <p:cNvSpPr/>
+          <p:nvPr/>
+        </p:nvSpPr>
+        <p:spPr>
+          <a:xfrm>
+            <a:off x="548640" y="4931229"/>
+            <a:ext cx="11094415" cy="0"/>
+          </a:xfrm>
+          <a:prstGeom prst="line">
+            <a:avLst/>
+          </a:prstGeom>
+          <a:noFill/>
+          <a:ln w="9525">
+            <a:solidFill>
+              <a:schemeClr val="accent4"/>
+            </a:solidFill>
+            <a:prstDash val="solid"/>
+          </a:ln>
+        </p:spPr>
+      </p:sp>
+      <p:sp>
+        <p:nvSpPr>
+          <p:cNvPr id="18" name="Text 16"/>
+          <p:cNvSpPr txBox="1"/>
+          <p:nvPr/>
+        </p:nvSpPr>
+        <p:spPr>
+          <a:xfrm>
+            <a:off x="731520" y="4265023"/>
+            <a:ext cx="2377440" cy="666206"/>
+          </a:xfrm>
+          <a:prstGeom prst="rect">
+            <a:avLst/>
+          </a:prstGeom>
+          <a:noFill/>
+          <a:ln/>
+        </p:spPr>
+        <p:txBody>
+          <a:bodyPr wrap="square" lIns="0" tIns="0" rIns="0" bIns="0" rtlCol="0" anchor="ctr"/>
+          <a:lstStyle/>
+          <a:p>
+            <a:pPr indent="0" marL="0">
+              <a:buNone/>
+            </a:pPr>
+            <a:r>
+              <a:rPr lang="en-US" sz="1000" b="1" spc="150" kern="0" dirty="0">
+                <a:solidFill>
+                  <a:schemeClr val="accent1"/>
                 </a:solidFill>
                 <a:latin typeface="Arial" pitchFamily="34" charset="0"/>
                 <a:ea typeface="Arial" pitchFamily="34" charset="-122"/>
                 <a:cs typeface="Arial" pitchFamily="34" charset="-120"/>
               </a:rPr>
-              <a:t> — описывает весь путь товара. Используем под логотипом и в объявлениях вместе со слоганом.</a:t>
-            </a:r>
-            <a:endParaRPr lang="en-US" sz="1250" dirty="0"/>
+              <a:t>5 · ПО БЛАГУ</a:t>
+            </a:r>
+            <a:endParaRPr lang="en-US" sz="1000" dirty="0"/>
+          </a:p>
+        </p:txBody>
+      </p:sp>
+      <p:sp>
+        <p:nvSpPr>
+          <p:cNvPr id="19" name="Text 17"/>
+          <p:cNvSpPr txBox="1"/>
+          <p:nvPr/>
+        </p:nvSpPr>
+        <p:spPr>
+          <a:xfrm>
+            <a:off x="3200400" y="4265023"/>
+            <a:ext cx="6766560" cy="666206"/>
+          </a:xfrm>
+          <a:prstGeom prst="rect">
+            <a:avLst/>
+          </a:prstGeom>
+          <a:noFill/>
+          <a:ln/>
+        </p:spPr>
+        <p:txBody>
+          <a:bodyPr wrap="square" lIns="0" tIns="0" rIns="0" bIns="0" rtlCol="0" anchor="ctr"/>
+          <a:lstStyle/>
+          <a:p>
+            <a:pPr indent="0" marL="0">
+              <a:buNone/>
+            </a:pPr>
+            <a:r>
+              <a:rPr lang="en-US" sz="2000" dirty="0">
+                <a:solidFill>
+                  <a:schemeClr val="tx1"/>
+                </a:solidFill>
+                <a:latin typeface="Arial Black" pitchFamily="34" charset="0"/>
+                <a:ea typeface="Arial Black" pitchFamily="34" charset="-122"/>
+                <a:cs typeface="Arial Black" pitchFamily="34" charset="-120"/>
+              </a:rPr>
+              <a:t>«Заказы вместо возвратов»</a:t>
+            </a:r>
+            <a:endParaRPr lang="en-US" sz="2000" dirty="0"/>
+          </a:p>
+        </p:txBody>
+      </p:sp>
+      <p:sp>
+        <p:nvSpPr>
+          <p:cNvPr id="20" name="main-slogan"/>
+          <p:cNvSpPr/>
+          <p:nvPr/>
+        </p:nvSpPr>
+        <p:spPr>
+          <a:xfrm>
+            <a:off x="548640" y="4949517"/>
+            <a:ext cx="11094415" cy="629630"/>
+          </a:xfrm>
+          <a:prstGeom prst="roundRect">
+            <a:avLst>
+              <a:gd name="adj" fmla="val 8714"/>
+            </a:avLst>
+          </a:prstGeom>
+          <a:solidFill>
+            <a:schemeClr val="accent1"/>
+          </a:solidFill>
+          <a:ln/>
+        </p:spPr>
+      </p:sp>
+      <p:sp>
+        <p:nvSpPr>
+          <p:cNvPr id="21" name="Text 19"/>
+          <p:cNvSpPr txBox="1"/>
+          <p:nvPr/>
+        </p:nvSpPr>
+        <p:spPr>
+          <a:xfrm>
+            <a:off x="731520" y="4931229"/>
+            <a:ext cx="2377440" cy="666206"/>
+          </a:xfrm>
+          <a:prstGeom prst="rect">
+            <a:avLst/>
+          </a:prstGeom>
+          <a:noFill/>
+          <a:ln/>
+        </p:spPr>
+        <p:txBody>
+          <a:bodyPr wrap="square" lIns="0" tIns="0" rIns="0" bIns="0" rtlCol="0" anchor="ctr"/>
+          <a:lstStyle/>
+          <a:p>
+            <a:pPr indent="0" marL="0">
+              <a:buNone/>
+            </a:pPr>
+            <a:r>
+              <a:rPr lang="en-US" sz="1000" b="1" spc="150" kern="0" dirty="0">
+                <a:solidFill>
+                  <a:schemeClr val="bg1"/>
+                </a:solidFill>
+                <a:latin typeface="Arial" pitchFamily="34" charset="0"/>
+                <a:ea typeface="Arial" pitchFamily="34" charset="-122"/>
+                <a:cs typeface="Arial" pitchFamily="34" charset="-120"/>
+              </a:rPr>
+              <a:t>6 · ПО ПРЕИМУЩЕСТВУ</a:t>
+            </a:r>
+            <a:endParaRPr lang="en-US" sz="1000" dirty="0"/>
+          </a:p>
+        </p:txBody>
+      </p:sp>
+      <p:sp>
+        <p:nvSpPr>
+          <p:cNvPr id="22" name="Text 20"/>
+          <p:cNvSpPr txBox="1"/>
+          <p:nvPr/>
+        </p:nvSpPr>
+        <p:spPr>
+          <a:xfrm>
+            <a:off x="3200400" y="4931229"/>
+            <a:ext cx="6766560" cy="666206"/>
+          </a:xfrm>
+          <a:prstGeom prst="rect">
+            <a:avLst/>
+          </a:prstGeom>
+          <a:noFill/>
+          <a:ln/>
+        </p:spPr>
+        <p:txBody>
+          <a:bodyPr wrap="square" lIns="0" tIns="0" rIns="0" bIns="0" rtlCol="0" anchor="ctr"/>
+          <a:lstStyle/>
+          <a:p>
+            <a:pPr indent="0" marL="0">
+              <a:buNone/>
+            </a:pPr>
+            <a:r>
+              <a:rPr lang="en-US" sz="2000" dirty="0">
+                <a:solidFill>
+                  <a:schemeClr val="bg1"/>
+                </a:solidFill>
+                <a:latin typeface="Arial Black" pitchFamily="34" charset="0"/>
+                <a:ea typeface="Arial Black" pitchFamily="34" charset="-122"/>
+                <a:cs typeface="Arial Black" pitchFamily="34" charset="-120"/>
+              </a:rPr>
+              <a:t>«Снято честно. Проверено кликом.»</a:t>
+            </a:r>
+            <a:endParaRPr lang="en-US" sz="2000" dirty="0"/>
+          </a:p>
+        </p:txBody>
+      </p:sp>
+      <p:sp>
+        <p:nvSpPr>
+          <p:cNvPr id="23" name="Shape 21"/>
+          <p:cNvSpPr/>
+          <p:nvPr/>
+        </p:nvSpPr>
+        <p:spPr>
+          <a:xfrm>
+            <a:off x="10317175" y="5108883"/>
+            <a:ext cx="1143000" cy="310896"/>
+          </a:xfrm>
+          <a:prstGeom prst="roundRect">
+            <a:avLst>
+              <a:gd name="adj" fmla="val 50000"/>
+            </a:avLst>
+          </a:prstGeom>
+          <a:ln w="9525">
+            <a:solidFill>
+              <a:schemeClr val="bg1"/>
+            </a:solidFill>
+            <a:prstDash val="solid"/>
+          </a:ln>
+        </p:spPr>
+      </p:sp>
+      <p:sp>
+        <p:nvSpPr>
+          <p:cNvPr id="24" name="Text 22"/>
+          <p:cNvSpPr txBox="1"/>
+          <p:nvPr/>
+        </p:nvSpPr>
+        <p:spPr>
+          <a:xfrm>
+            <a:off x="10317175" y="5108883"/>
+            <a:ext cx="1143000" cy="310896"/>
+          </a:xfrm>
+          <a:prstGeom prst="rect">
+            <a:avLst/>
+          </a:prstGeom>
+          <a:noFill/>
+          <a:ln/>
+        </p:spPr>
+        <p:txBody>
+          <a:bodyPr wrap="square" lIns="0" tIns="0" rIns="0" bIns="0" rtlCol="0" anchor="ctr"/>
+          <a:lstStyle/>
+          <a:p>
+            <a:pPr algn="ctr" indent="0" marL="0">
+              <a:buNone/>
+            </a:pPr>
+            <a:r>
+              <a:rPr lang="en-US" sz="950" b="1" spc="150" kern="0" dirty="0">
+                <a:solidFill>
+                  <a:schemeClr val="bg1"/>
+                </a:solidFill>
+                <a:latin typeface="Arial" pitchFamily="34" charset="0"/>
+                <a:ea typeface="Arial" pitchFamily="34" charset="-122"/>
+                <a:cs typeface="Arial" pitchFamily="34" charset="-120"/>
+              </a:rPr>
+              <a:t>ОСНОВНОЙ</a:t>
+            </a:r>
+            <a:endParaRPr lang="en-US" sz="950" dirty="0"/>
+          </a:p>
+        </p:txBody>
+      </p:sp>
+      <p:sp>
+        <p:nvSpPr>
+          <p:cNvPr id="25" name="Shape 23"/>
+          <p:cNvSpPr/>
+          <p:nvPr/>
+        </p:nvSpPr>
+        <p:spPr>
+          <a:xfrm>
+            <a:off x="548640" y="6263640"/>
+            <a:ext cx="11094415" cy="0"/>
+          </a:xfrm>
+          <a:prstGeom prst="line">
+            <a:avLst/>
+          </a:prstGeom>
+          <a:noFill/>
+          <a:ln w="9525">
+            <a:solidFill>
+              <a:schemeClr val="accent4"/>
+            </a:solidFill>
+            <a:prstDash val="solid"/>
+          </a:ln>
+        </p:spPr>
+      </p:sp>
+      <p:sp>
+        <p:nvSpPr>
+          <p:cNvPr id="26" name="Text 24"/>
+          <p:cNvSpPr txBox="1"/>
+          <p:nvPr/>
+        </p:nvSpPr>
+        <p:spPr>
+          <a:xfrm>
+            <a:off x="731520" y="5597434"/>
+            <a:ext cx="2377440" cy="666206"/>
+          </a:xfrm>
+          <a:prstGeom prst="rect">
+            <a:avLst/>
+          </a:prstGeom>
+          <a:noFill/>
+          <a:ln/>
+        </p:spPr>
+        <p:txBody>
+          <a:bodyPr wrap="square" lIns="0" tIns="0" rIns="0" bIns="0" rtlCol="0" anchor="ctr"/>
+          <a:lstStyle/>
+          <a:p>
+            <a:pPr indent="0" marL="0">
+              <a:buNone/>
+            </a:pPr>
+            <a:r>
+              <a:rPr lang="en-US" sz="1000" b="1" spc="150" kern="0" dirty="0">
+                <a:solidFill>
+                  <a:schemeClr val="accent1"/>
+                </a:solidFill>
+                <a:latin typeface="Arial" pitchFamily="34" charset="0"/>
+                <a:ea typeface="Arial" pitchFamily="34" charset="-122"/>
+                <a:cs typeface="Arial" pitchFamily="34" charset="-120"/>
+              </a:rPr>
+              <a:t>7 · ПО КОНКУРЕНТУ</a:t>
+            </a:r>
+            <a:endParaRPr lang="en-US" sz="1000" dirty="0"/>
+          </a:p>
+        </p:txBody>
+      </p:sp>
+      <p:sp>
+        <p:nvSpPr>
+          <p:cNvPr id="27" name="Text 25"/>
+          <p:cNvSpPr txBox="1"/>
+          <p:nvPr/>
+        </p:nvSpPr>
+        <p:spPr>
+          <a:xfrm>
+            <a:off x="3200400" y="5597434"/>
+            <a:ext cx="6766560" cy="666206"/>
+          </a:xfrm>
+          <a:prstGeom prst="rect">
+            <a:avLst/>
+          </a:prstGeom>
+          <a:noFill/>
+          <a:ln/>
+        </p:spPr>
+        <p:txBody>
+          <a:bodyPr wrap="square" lIns="0" tIns="0" rIns="0" bIns="0" rtlCol="0" anchor="ctr"/>
+          <a:lstStyle/>
+          <a:p>
+            <a:pPr indent="0" marL="0">
+              <a:buNone/>
+            </a:pPr>
+            <a:r>
+              <a:rPr lang="en-US" sz="2000" dirty="0">
+                <a:solidFill>
+                  <a:schemeClr val="tx1"/>
+                </a:solidFill>
+                <a:latin typeface="Arial Black" pitchFamily="34" charset="0"/>
+                <a:ea typeface="Arial Black" pitchFamily="34" charset="-122"/>
+                <a:cs typeface="Arial Black" pitchFamily="34" charset="-120"/>
+              </a:rPr>
+              <a:t>«Честнее ИИ. Полнее студии.»</a:t>
+            </a:r>
+            <a:endParaRPr lang="en-US" sz="2000" dirty="0"/>
           </a:p>
         </p:txBody>
       </p:sp>

</xml_diff>